<commit_message>
Refresh SANCHAY.pptx with high-res TUI screenshots and typography updates
</commit_message>
<xml_diff>
--- a/docs/SANCHAY.pptx
+++ b/docs/SANCHAY.pptx
@@ -3207,7 +3207,7 @@
                 </a:solidFill>
                 <a:latin typeface="Segoe UI"/>
               </a:rPr>
-              <a:t>C-DAC / MeitY AI Enabled OS Hackathon 2026  ·  Track: AI at Application Level</a:t>
+              <a:t>C-DAC / MeitY AI Enabled OS Hackathon 2026  •  Track: AI at Application Level</a:t>
             </a:r>
           </a:p>
           <a:p>
@@ -3223,7 +3223,7 @@
                 </a:solidFill>
                 <a:latin typeface="Segoe UI"/>
               </a:rPr>
-              <a:t>AI-Powered Intelligent Storage Optimizer for Linux OS  ·  Shaik Abdul Basith, Shaik Awaiz, Shaik Abdul Muqeeth</a:t>
+              <a:t>AI-Powered Intelligent Storage Optimizer for Linux OS  •  Shaik Abdul Basith, Shaik Awaiz, Shaik Abdul Muqeeth</a:t>
             </a:r>
           </a:p>
         </p:txBody>
@@ -3374,7 +3374,7 @@
                 </a:solidFill>
                 <a:latin typeface="Segoe UI"/>
               </a:rPr>
-              <a:t>final year project.</a:t>
+              <a:t>capstone project.</a:t>
             </a:r>
           </a:p>
           <a:p>
@@ -3406,7 +3406,7 @@
                 </a:solidFill>
                 <a:latin typeface="Segoe UI"/>
               </a:rPr>
-              <a:t>Both are 2 GB. On a treemap they are the same shade of big. Every existing tool —</a:t>
+              <a:t>Both are 2 GB. On a traditional treemap they look identical. Every existing tool —</a:t>
             </a:r>
           </a:p>
           <a:p>
@@ -3422,7 +3422,7 @@
                 </a:solidFill>
                 <a:latin typeface="Segoe UI"/>
               </a:rPr>
-              <a:t>rmlint, fdupes, jdupes, Czkawka, Baobab, QDirStat, ncdu — ranks them identically,</a:t>
+              <a:t>rmlint, fdupes, jdupes, Czkawka, Baobab, QDirStat, ncdu — ranks them the same.</a:t>
             </a:r>
           </a:p>
           <a:p>
@@ -3438,7 +3438,7 @@
                 </a:solidFill>
                 <a:latin typeface="Segoe UI"/>
               </a:rPr>
-              <a:t>because by their measure the two really are identical.</a:t>
+              <a:t/>
             </a:r>
           </a:p>
           <a:p>
@@ -3454,23 +3454,7 @@
                 </a:solidFill>
                 <a:latin typeface="Segoe UI"/>
               </a:rPr>
-              <a:t/>
-            </a:r>
-          </a:p>
-          <a:p>
-            <a:pPr>
-              <a:spcAft>
-                <a:spcPts val="1000"/>
-              </a:spcAft>
-            </a:pPr>
-            <a:r>
-              <a:rPr sz="1900" b="0" i="0">
-                <a:solidFill>
-                  <a:srgbClr val="0F172A"/>
-                </a:solidFill>
-                <a:latin typeface="Segoe UI"/>
-              </a:rPr>
-              <a:t>But one comes back with npm install. The other is gone forever.</a:t>
+              <a:t>One comes back with npm install / cargo build. The other is gone forever.</a:t>
             </a:r>
           </a:p>
         </p:txBody>
@@ -3605,7 +3589,7 @@
                 </a:solidFill>
                 <a:latin typeface="Segoe UI"/>
               </a:rPr>
-              <a:t>priority  =  size  x  how long untouched  x  how safe it is to lose</a:t>
+              <a:t>priority  =  size  ×  how long untouched  ×  how safe it is to lose</a:t>
             </a:r>
           </a:p>
         </p:txBody>
@@ -4247,7 +4231,7 @@
                 </a:solidFill>
                 <a:latin typeface="Segoe UI"/>
               </a:rPr>
-              <a:t>Most AI system tools try to make the model behave safely by prompting it carefully.</a:t>
+              <a:t>Most AI system tools try to make the model behave safely through careful prompting.</a:t>
             </a:r>
           </a:p>
           <a:p>
@@ -4263,7 +4247,7 @@
                 </a:solidFill>
                 <a:latin typeface="Segoe UI"/>
               </a:rPr>
-              <a:t>We gave it no way to cause the harm instead.</a:t>
+              <a:t>We gave the model no structural way to cause harm instead.</a:t>
             </a:r>
           </a:p>
           <a:p>
@@ -4295,7 +4279,7 @@
                 </a:solidFill>
                 <a:latin typeface="Segoe UI"/>
               </a:rPr>
-              <a:t>The ranking finishes before the model is called. The model receives only files already</a:t>
+              <a:t>Ranking completes before the LLM is called. The model receives only files already</a:t>
             </a:r>
           </a:p>
           <a:p>
@@ -4311,7 +4295,7 @@
                 </a:solidFill>
                 <a:latin typeface="Segoe UI"/>
               </a:rPr>
-              <a:t>judged recoverable. It cannot add a file, remove one, or change the order.</a:t>
+              <a:t>judged recoverable. It cannot add a file, delete a file, or modify priority.</a:t>
             </a:r>
           </a:p>
           <a:p>
@@ -4343,23 +4327,7 @@
                 </a:solidFill>
                 <a:latin typeface="Segoe UI"/>
               </a:rPr>
-              <a:t>If it produced a completely wrong answer, the worst outcome is an awkward sentence —</a:t>
-            </a:r>
-          </a:p>
-          <a:p>
-            <a:pPr>
-              <a:spcAft>
-                <a:spcPts val="1000"/>
-              </a:spcAft>
-            </a:pPr>
-            <a:r>
-              <a:rPr sz="1900" b="0" i="0">
-                <a:solidFill>
-                  <a:srgbClr val="0F172A"/>
-                </a:solidFill>
-                <a:latin typeface="Segoe UI"/>
-              </a:rPr>
-              <a:t>never a lost file.</a:t>
+              <a:t>If the LLM hallucinates, the worst outcome is an awkward description — never data loss.</a:t>
             </a:r>
           </a:p>
         </p:txBody>
@@ -4494,7 +4462,7 @@
                 </a:solidFill>
                 <a:latin typeface="Segoe UI"/>
               </a:rPr>
-              <a:t>Predicting when a disk fills normally means running an agent for weeks first.</a:t>
+              <a:t>Predicting disk exhaustion usually requires running a daemon for weeks.</a:t>
             </a:r>
           </a:p>
           <a:p>
@@ -4526,7 +4494,7 @@
                 </a:solidFill>
                 <a:latin typeface="Segoe UI"/>
               </a:rPr>
-              <a:t>It does not have to. Every file already records the day it was written, so the spread of</a:t>
+              <a:t>It does not have to. Every filesystem already stores file modification timestamps,</a:t>
             </a:r>
           </a:p>
           <a:p>
@@ -4542,7 +4510,7 @@
                 </a:solidFill>
                 <a:latin typeface="Segoe UI"/>
               </a:rPr>
-              <a:t>modification times across a single scan is the history — bytes added per day, free.</a:t>
+              <a:t>so the mtime distribution across a single scan gives bytes-added-per-day directly.</a:t>
             </a:r>
           </a:p>
           <a:p>
@@ -4574,7 +4542,7 @@
                 </a:solidFill>
                 <a:latin typeface="Segoe UI"/>
               </a:rPr>
-              <a:t>Against current free space, that gives a date on the first run.</a:t>
+              <a:t>Compared against free space, that yields an immediate runway forecast on run #1.</a:t>
             </a:r>
           </a:p>
         </p:txBody>
@@ -4613,7 +4581,7 @@
                 </a:solidFill>
                 <a:latin typeface="Segoe UI"/>
               </a:rPr>
-              <a:t>growth:  91.2 MB/day,  full in 137 days</a:t>
+              <a:t>growth:  33.9 KB/day  |  immediate exhaustion date projection</a:t>
             </a:r>
           </a:p>
         </p:txBody>
@@ -4731,7 +4699,7 @@
         <p:spPr>
           <a:xfrm>
             <a:off x="1463040" y="1691640"/>
-            <a:ext cx="9235440" cy="6081635"/>
+            <a:ext cx="9235440" cy="5777062"/>
           </a:xfrm>
           <a:prstGeom prst="rect">
             <a:avLst/>
@@ -4910,7 +4878,7 @@
                 </a:solidFill>
                 <a:latin typeface="Segoe UI"/>
               </a:rPr>
-              <a:t>HONESTY</a:t>
+              <a:t>TECHNICAL STACK &amp; TRANSPARENCY</a:t>
             </a:r>
           </a:p>
         </p:txBody>
@@ -4988,7 +4956,7 @@
                 </a:solidFill>
                 <a:latin typeface="Segoe UI"/>
               </a:rPr>
-              <a:t>Ours:  the scanner, the duplicate finder, the regret model, the forecaster.</a:t>
+              <a:t>Built by us: fast metadata scanner, tiered content hasher, regret classifier, and forecaster.</a:t>
             </a:r>
           </a:p>
           <a:p>
@@ -5020,7 +4988,7 @@
                 </a:solidFill>
                 <a:latin typeface="Segoe UI"/>
               </a:rPr>
-              <a:t>Borrowed:  Textual (MIT) for the interface · plotly and pandas for the treemap ·</a:t>
+              <a:t>Libraries: Textual (MIT) for TUI • Plotly &amp; Pandas for interactive treemap •</a:t>
             </a:r>
           </a:p>
           <a:p>
@@ -5036,7 +5004,7 @@
                 </a:solidFill>
                 <a:latin typeface="Segoe UI"/>
               </a:rPr>
-              <a:t>anthropic (MIT) to write the summary. The core installs with zero dependencies.</a:t>
+              <a:t>Anthropic API (MIT) for natural-language narration. Core runs with zero 3rd-party deps.</a:t>
             </a:r>
           </a:p>
           <a:p>
@@ -5068,7 +5036,7 @@
                 </a:solidFill>
                 <a:latin typeface="Segoe UI"/>
               </a:rPr>
-              <a:t>One bug worth admitting: our first version treated any file inside a git repository as</a:t>
+              <a:t>Real refinement: initial version treated all files in a git repo as safe. Git cannot</a:t>
             </a:r>
           </a:p>
           <a:p>
@@ -5084,7 +5052,7 @@
                 </a:solidFill>
                 <a:latin typeface="Segoe UI"/>
               </a:rPr>
-              <a:t>recoverable. That is wrong — git cannot restore a file it never tracked. We now ask git</a:t>
+              <a:t>restore untracked files, so we now query git index status directly to strictly protect</a:t>
             </a:r>
           </a:p>
           <a:p>
@@ -5100,23 +5068,7 @@
                 </a:solidFill>
                 <a:latin typeface="Segoe UI"/>
               </a:rPr>
-              <a:t>what it actually tracks. On our test tree that moved 34 files out of "safe to delete"</a:t>
-            </a:r>
-          </a:p>
-          <a:p>
-            <a:pPr>
-              <a:spcAft>
-                <a:spcPts val="900"/>
-              </a:spcAft>
-            </a:pPr>
-            <a:r>
-              <a:rPr sz="1800" b="0" i="0">
-                <a:solidFill>
-                  <a:srgbClr val="0F172A"/>
-                </a:solidFill>
-                <a:latin typeface="Segoe UI"/>
-              </a:rPr>
-              <a:t>and into the protected set.</a:t>
+              <a:t>untracked files.</a:t>
             </a:r>
           </a:p>
         </p:txBody>

</xml_diff>